<commit_message>
Contrôle final : tailles de texte, contraste du graphique, style des notes, renvois du corrigé
Co-Authored-By: Claude Opus 5.5 <noreply@anthropic.com>
Claude-Session: https://claude.ai/code/session_01GbhFBcrtpyC2sV66BSB76r
</commit_message>
<xml_diff>
--- a/formation-powerbi/01_presentation/Initiation_Power_BI.pptx
+++ b/formation-powerbi/01_presentation/Initiation_Power_BI.pptx
@@ -174,7 +174,7 @@
           </c:tx>
           <c:spPr>
             <a:solidFill>
-              <a:srgbClr val="A3A39E"/>
+              <a:srgbClr val="8C8C87"/>
             </a:solidFill>
             <a:effectLst/>
           </c:spPr>
@@ -499,7 +499,7 @@
           <a:lstStyle/>
           <a:p>
             <a:pPr>
-              <a:defRPr sz="1400" b="0" i="0" u="none" strike="noStrike">
+              <a:defRPr sz="1600" b="0" i="0" u="none" strike="noStrike">
                 <a:solidFill>
                   <a:srgbClr val="5E5E5E"/>
                 </a:solidFill>
@@ -2066,7 +2066,7 @@
           <a:p>
             <a:r>
               <a:rPr lang="en-US" dirty="0"/>
-              <a:t>Erreur n°4. Une slide sans image, volontairement : c'est une règle d'ordre, il faut qu'elle se lise de loin.
+              <a:t>Erreur n°4. Une slide sans image, volontairement : c'est une question d'ordre des étapes, elle doit se lire de loin.
 L'histoire : quelqu'un a recollé dans l'export une semaine de juin déjà présente. Les 30 lignes sont des copies, sauf que le système qui les a sorties ajoute un espace après le code magasin. « MAG-03 » et « MAG-03 espace ».
 Si on fait Supprimer les doublons d'abord, Power Query compare les lignes et les trouve différentes : il ne supprime rien. Le CA est surestimé de 2 001,50 MAD. Si on supprime les espaces d'abord, les lignes deviennent identiques, et Supprimer les doublons fait son travail.
 Deuxième piège, que je vois à chaque session : Supprimer les doublons ne regarde QUE les colonnes sélectionnées. Si vous avez seulement la colonne Code magasin sélectionnée, il garde une ligne par magasin. Vous passez de 5 189 lignes à 13. Avant de dédoublonner une table entière : clic sur l'en-tête de la première colonne, Ctrl+A, puis Supprimer les doublons.
@@ -2349,7 +2349,7 @@
               <a:t>Retour de déjeuner, 13h30. Tout le monde ouvre ma_formation.pbix ou R2_nettoye.pbix.
 Je ne fais pas d'introduction. Je demande directement : « Vue Rapport, visuel Table, glissez la ville de Magasins et la quantité de Ventes. » Deux minutes. Ça réveille, et ça produit une erreur.
 Résultat : chaque ville affiche le même nombre, qui est le total général. Je laisse les gens réagir. Il y a toujours quelqu'un pour dire « c'est cassé ».
-« Ce n'est pas cassé, c'est logique. Pour Power BI, la table Magasins et la table Ventes sont deux fichiers qui ne se connaissent pas. Il ne sait pas quelle vente appartient à quel magasin. Dans Excel, vous auriez fait une RECHERCHEV. Ici, on fait une relation, une fois pour toutes. »
+« Rien n'est cassé. Pour Power BI, la table Magasins et la table Ventes sont deux fichiers qui ne se connaissent pas. Il ne sait pas quelle vente appartient à quel magasin. Dans Excel, vous auriez fait une RECHERCHEV. Ici, on fait une relation, une fois pour toutes. »
 C'est pour ça qu'on a décoché la détection automatique ce matin : sinon Power BI l'aurait devinée, et vous n'auriez jamais vu ce qui se passe sans elle.</a:t>
             </a:r>
             <a:endParaRPr lang="en-US" dirty="0"/>
@@ -3847,7 +3847,7 @@
               <a:rPr lang="en-US" dirty="0"/>
               <a:t>6 minutes. Je ne fais pas un cours de design de tableau de bord, je donne une règle de lecture simple : en haut ce qu'on regarde en trois secondes, au milieu l'évolution, en bas le détail.
 Les numéros sur la slide sont l'ordre de lecture, pas un ordre de construction.
-Trois conseils que je donne à l'oral :
+Ce que je dis à l'oral :
 - une page répond à une question. Celle-ci répond à « comment vont les ventes ? ». Si vous avez une autre question (les stocks, les marges), faites une autre page ;
 - pas plus de cinq ou six visuels par page. Au-delà, personne ne lit ;
 - les segments en haut ou sur le côté, toujours au même endroit d'une page à l'autre.
@@ -3943,7 +3943,7 @@
               <a:t>25 minutes. C'est le TP où les gens prennent du plaisir, et où ils perdent le plus de temps sur la mise en forme. Je préviens : « On ne passe pas 10 minutes sur la couleur d'un titre. Le contenu d'abord. »
 Ce qui bloque d'habitude :
 - La carte affiche « Nombre de Date » ou une somme bizarre : ils ont glissé une colonne au lieu de la mesure. Les mesures sont celles avec l'icône de calculatrice.
-- Le graphique mensuel mélange 2025 et 2026 : c'est normal sans segment, le segment Année règle ça. Je les laisse le découvrir.
+- Le graphique mensuel mélange 2025 et 2026 : c'est normal sans segment, le segment Année règle ça. Je les laisse trouver.
 - La matrice affiche les mois en vrac : ils ont mis Mois au lieu de Année, ou le tri par colonne n'est pas fait.
 Pour finir, je demande à deux volontaires de projeter leur page. On commente ce qui marche, avec bienveillance. C'est souvent le moment où la salle réalise qu'elle a fait en une journée ce qui lui prend une matinée chaque semaine.
 À 16h08 : enregistrez. Ce fichier est à vous, vous repartez avec.</a:t>
@@ -4034,7 +4034,7 @@
           <a:p>
             <a:r>
               <a:rPr lang="en-US" dirty="0"/>
-              <a:t>Démo de 10 minutes. C'est le moment « wow » de la journée, il faut qu'il soit fluide : répétez-la la veille.
+              <a:t>Démo de 10 minutes. C'est le moment « wow » de la journée, il ne doit pas accrocher : répétez-la la veille.
 Je passe sur Power BI (R5_rapport.pbix déjà ouvert). Ce que je montre, dans cet ordre :
 1. Je clique sur Casablanca dans le graphique en barres : toute la page se filtre. « Pas de formule à changer, pas de TCD à refaire. »
 2. Je change l'année dans le segment.
@@ -4228,7 +4228,7 @@
               <a:rPr lang="en-US" dirty="0"/>
               <a:t>Deux minutes, pas plus. C'est le plan de la journée, mais je le présente comme le chemin que suit la donnée : on l'importe, on la nettoie, on relie les tables, on calcule, on montre.
 « Ce matin, on ne fait QUE les deux premières étapes. Ça paraît beaucoup de temps pour du nettoyage. En vrai, c'est là que se joue 80 % de la qualité de votre rapport. »
-Je précise le fonctionnement : je montre, vous faites, et pour chaque TP il y a un fichier de rattrapage. « Si vous décrochez, vous ne restez pas bloqué : vous ouvrez le fichier de rattrapage et vous repartez avec tout le monde. Ce n'est pas un échec, c'est prévu. »
+Je précise le fonctionnement : je montre, vous faites, et pour chaque TP il y a un fichier de rattrapage. « Si vous décrochez, vous ne restez pas bloqué : vous ouvrez le fichier de rattrapage et vous repartez avec tout le monde. C'est prévu pour ça. »
 Je ne repasserai pas cette slide. À chaque début de module, je redis juste en une phrase où on en est sur ce trajet.</a:t>
             </a:r>
             <a:endParaRPr lang="en-US" dirty="0"/>
@@ -4413,7 +4413,7 @@
               <a:rPr lang="en-US" dirty="0"/>
               <a:t>Mise en commun, 3 minutes. Je demande d'abord : « Combien de problèmes avez-vous trouvé ? » Et je fais monter les enchères : trois, cinq, six... Le binôme qui en a le plus les liste, les autres complètent.
 Puis je révèle la slide. Les sept pièges sont listés en bas à droite.
-Le huitième, je ne le dis pas : c'est le magasin MAG-13, ouvert en mars 2026 à Kénitra, qui vend mais n'existe pas dans la feuille Magasins. On le découvrira en faisant le modèle, cet après-midi. Je garde le suspense, ça marche bien.
+Le huitième, je ne le dis pas : c'est le magasin MAG-13, ouvert en mars 2026 à Kénitra, qui vend mais n'existe pas dans la feuille Magasins. On tombera dessus cet après-midi, en faisant le modèle. Je garde le suspense, ça marche bien.
 Le point à faire passer : « Ce fichier n'est pas un fichier pourri que j'ai inventé pour vous embêter. Chacun de ces défauts, je l'ai vu dans de vrais exports. Et dans Excel, vous les corrigez à la main, chaque semaine. Dans Power BI, vous les corrigez une fois. »
 Transition vers le module 1 : « On ouvre Power BI. »</a:t>
             </a:r>
@@ -7817,8 +7817,8 @@
         </p:nvSpPr>
         <p:spPr>
           <a:xfrm flipH="1">
-            <a:off x="6400800" y="1783080"/>
-            <a:ext cx="365760" cy="347472"/>
+            <a:off x="5943600" y="1783080"/>
+            <a:ext cx="320040" cy="347472"/>
           </a:xfrm>
           <a:prstGeom prst="line">
             <a:avLst/>
@@ -7841,8 +7841,8 @@
         </p:nvSpPr>
         <p:spPr>
           <a:xfrm>
-            <a:off x="6858000" y="1572768"/>
-            <a:ext cx="4206240" cy="320040"/>
+            <a:off x="6355080" y="1536192"/>
+            <a:ext cx="5303520" cy="365760"/>
           </a:xfrm>
           <a:prstGeom prst="rect">
             <a:avLst/>
@@ -7858,7 +7858,7 @@
               <a:buNone/>
             </a:pPr>
             <a:r>
-              <a:rPr lang="en-US" sz="1600" dirty="0">
+              <a:rPr lang="en-US" sz="1800" dirty="0">
                 <a:solidFill>
                   <a:srgbClr val="C8261D"/>
                 </a:solidFill>
@@ -7868,7 +7868,7 @@
               </a:rPr>
               <a:t>Barre de formule : Affichage &gt; Barre de formule</a:t>
             </a:r>
-            <a:endParaRPr lang="en-US" sz="1600" dirty="0"/>
+            <a:endParaRPr lang="en-US" sz="1800" dirty="0"/>
           </a:p>
         </p:txBody>
       </p:sp>
@@ -15171,7 +15171,7 @@
               <a:buNone/>
             </a:pPr>
             <a:r>
-              <a:rPr lang="en-US" sz="1600" dirty="0">
+              <a:rPr lang="en-US" sz="1800" dirty="0">
                 <a:solidFill>
                   <a:srgbClr val="5E5E5E"/>
                 </a:solidFill>
@@ -15181,7 +15181,7 @@
               </a:rPr>
               <a:t>1</a:t>
             </a:r>
-            <a:endParaRPr lang="en-US" sz="1600" dirty="0"/>
+            <a:endParaRPr lang="en-US" sz="1800" dirty="0"/>
           </a:p>
         </p:txBody>
       </p:sp>
@@ -15210,7 +15210,7 @@
               <a:buNone/>
             </a:pPr>
             <a:r>
-              <a:rPr lang="en-US" sz="1600" dirty="0">
+              <a:rPr lang="en-US" sz="1800" dirty="0">
                 <a:solidFill>
                   <a:srgbClr val="5E5E5E"/>
                 </a:solidFill>
@@ -15220,7 +15220,7 @@
               </a:rPr>
               <a:t>*</a:t>
             </a:r>
-            <a:endParaRPr lang="en-US" sz="1600" dirty="0"/>
+            <a:endParaRPr lang="en-US" sz="1800" dirty="0"/>
           </a:p>
         </p:txBody>
       </p:sp>
@@ -15312,7 +15312,7 @@
               <a:buNone/>
             </a:pPr>
             <a:r>
-              <a:rPr lang="en-US" sz="1600" dirty="0">
+              <a:rPr lang="en-US" sz="1800" dirty="0">
                 <a:solidFill>
                   <a:srgbClr val="5E5E5E"/>
                 </a:solidFill>
@@ -15322,7 +15322,7 @@
               </a:rPr>
               <a:t>*</a:t>
             </a:r>
-            <a:endParaRPr lang="en-US" sz="1600" dirty="0"/>
+            <a:endParaRPr lang="en-US" sz="1800" dirty="0"/>
           </a:p>
         </p:txBody>
       </p:sp>
@@ -15351,7 +15351,7 @@
               <a:buNone/>
             </a:pPr>
             <a:r>
-              <a:rPr lang="en-US" sz="1600" dirty="0">
+              <a:rPr lang="en-US" sz="1800" dirty="0">
                 <a:solidFill>
                   <a:srgbClr val="5E5E5E"/>
                 </a:solidFill>
@@ -15361,7 +15361,7 @@
               </a:rPr>
               <a:t>1</a:t>
             </a:r>
-            <a:endParaRPr lang="en-US" sz="1600" dirty="0"/>
+            <a:endParaRPr lang="en-US" sz="1800" dirty="0"/>
           </a:p>
         </p:txBody>
       </p:sp>
@@ -15419,7 +15419,7 @@
           </p:nvPr>
         </p:nvGraphicFramePr>
         <p:xfrm>
-          <a:off x="9582912" y="2103120"/>
+          <a:off x="9601200" y="2103120"/>
           <a:ext cx="2011680" cy="914400"/>
         </p:xfrm>
         <a:graphic>
@@ -15427,10 +15427,10 @@
             <a:tbl>
               <a:tblPr/>
               <a:tblGrid>
-                <a:gridCol w="1051560"/>
-                <a:gridCol w="960120"/>
+                <a:gridCol w="1325880"/>
+                <a:gridCol w="685800"/>
               </a:tblGrid>
-              <a:tr h="329184">
+              <a:tr h="365760">
                 <a:tc>
                   <a:txBody>
                     <a:bodyPr/>
@@ -15440,7 +15440,7 @@
                         <a:buNone/>
                       </a:pPr>
                       <a:r>
-                        <a:rPr lang="en-US" sz="1600" b="1" dirty="0">
+                        <a:rPr lang="en-US" sz="1800" b="1" dirty="0">
                           <a:solidFill>
                             <a:srgbClr val="222222"/>
                           </a:solidFill>
@@ -15450,7 +15450,7 @@
                         </a:rPr>
                         <a:t>Catégorie</a:t>
                       </a:r>
-                      <a:endParaRPr lang="en-US" sz="1600" dirty="0">
+                      <a:endParaRPr lang="en-US" sz="1800" dirty="0">
                         <a:latin typeface="Source Sans 3" charset="0"/>
                         <a:ea typeface="Source Sans 3" charset="0"/>
                         <a:cs typeface="Source Sans 3" charset="0"/>
@@ -15505,7 +15505,7 @@
                         <a:buNone/>
                       </a:pPr>
                       <a:r>
-                        <a:rPr lang="en-US" sz="1600" b="1" dirty="0">
+                        <a:rPr lang="en-US" sz="1800" b="1" dirty="0">
                           <a:solidFill>
                             <a:srgbClr val="222222"/>
                           </a:solidFill>
@@ -15513,9 +15513,9 @@
                           <a:ea typeface="Source Sans 3" pitchFamily="34" charset="-122"/>
                           <a:cs typeface="Source Sans 3" pitchFamily="34" charset="-120"/>
                         </a:rPr>
-                        <a:t>Magasins</a:t>
+                        <a:t>Nb</a:t>
                       </a:r>
-                      <a:endParaRPr lang="en-US" sz="1600" dirty="0">
+                      <a:endParaRPr lang="en-US" sz="1800" dirty="0">
                         <a:latin typeface="Source Sans 3" charset="0"/>
                         <a:ea typeface="Source Sans 3" charset="0"/>
                         <a:cs typeface="Source Sans 3" charset="0"/>
@@ -15562,7 +15562,7 @@
                   </a:tcPr>
                 </a:tc>
               </a:tr>
-              <a:tr h="329184">
+              <a:tr h="365760">
                 <a:tc>
                   <a:txBody>
                     <a:bodyPr/>
@@ -15572,7 +15572,7 @@
                         <a:buNone/>
                       </a:pPr>
                       <a:r>
-                        <a:rPr lang="en-US" sz="1600" dirty="0">
+                        <a:rPr lang="en-US" sz="1800" dirty="0">
                           <a:solidFill>
                             <a:srgbClr val="222222"/>
                           </a:solidFill>
@@ -15582,7 +15582,7 @@
                         </a:rPr>
                         <a:t>Boissons</a:t>
                       </a:r>
-                      <a:endParaRPr lang="en-US" sz="1600" dirty="0">
+                      <a:endParaRPr lang="en-US" sz="1800" dirty="0">
                         <a:latin typeface="Source Sans 3" charset="0"/>
                         <a:ea typeface="Source Sans 3" charset="0"/>
                         <a:cs typeface="Source Sans 3" charset="0"/>
@@ -15637,7 +15637,7 @@
                         <a:buNone/>
                       </a:pPr>
                       <a:r>
-                        <a:rPr lang="en-US" sz="1600" dirty="0">
+                        <a:rPr lang="en-US" sz="1800" dirty="0">
                           <a:solidFill>
                             <a:srgbClr val="C8261D"/>
                           </a:solidFill>
@@ -15647,7 +15647,7 @@
                         </a:rPr>
                         <a:t>12</a:t>
                       </a:r>
-                      <a:endParaRPr lang="en-US" sz="1600" dirty="0">
+                      <a:endParaRPr lang="en-US" sz="1800" dirty="0">
                         <a:latin typeface="Source Sans 3" charset="0"/>
                         <a:ea typeface="Source Sans 3" charset="0"/>
                         <a:cs typeface="Source Sans 3" charset="0"/>
@@ -15694,7 +15694,7 @@
                   </a:tcPr>
                 </a:tc>
               </a:tr>
-              <a:tr h="329184">
+              <a:tr h="365760">
                 <a:tc>
                   <a:txBody>
                     <a:bodyPr/>
@@ -15704,7 +15704,7 @@
                         <a:buNone/>
                       </a:pPr>
                       <a:r>
-                        <a:rPr lang="en-US" sz="1600" dirty="0">
+                        <a:rPr lang="en-US" sz="1800" dirty="0">
                           <a:solidFill>
                             <a:srgbClr val="222222"/>
                           </a:solidFill>
@@ -15714,7 +15714,7 @@
                         </a:rPr>
                         <a:t>Épicerie</a:t>
                       </a:r>
-                      <a:endParaRPr lang="en-US" sz="1600" dirty="0">
+                      <a:endParaRPr lang="en-US" sz="1800" dirty="0">
                         <a:latin typeface="Source Sans 3" charset="0"/>
                         <a:ea typeface="Source Sans 3" charset="0"/>
                         <a:cs typeface="Source Sans 3" charset="0"/>
@@ -15769,7 +15769,7 @@
                         <a:buNone/>
                       </a:pPr>
                       <a:r>
-                        <a:rPr lang="en-US" sz="1600" dirty="0">
+                        <a:rPr lang="en-US" sz="1800" dirty="0">
                           <a:solidFill>
                             <a:srgbClr val="C8261D"/>
                           </a:solidFill>
@@ -15779,7 +15779,7 @@
                         </a:rPr>
                         <a:t>12</a:t>
                       </a:r>
-                      <a:endParaRPr lang="en-US" sz="1600" dirty="0">
+                      <a:endParaRPr lang="en-US" sz="1800" dirty="0">
                         <a:latin typeface="Source Sans 3" charset="0"/>
                         <a:ea typeface="Source Sans 3" charset="0"/>
                         <a:cs typeface="Source Sans 3" charset="0"/>
@@ -15826,7 +15826,7 @@
                   </a:tcPr>
                 </a:tc>
               </a:tr>
-              <a:tr h="329184">
+              <a:tr h="365760">
                 <a:tc>
                   <a:txBody>
                     <a:bodyPr/>
@@ -15836,7 +15836,7 @@
                         <a:buNone/>
                       </a:pPr>
                       <a:r>
-                        <a:rPr lang="en-US" sz="1600" dirty="0">
+                        <a:rPr lang="en-US" sz="1800" dirty="0">
                           <a:solidFill>
                             <a:srgbClr val="222222"/>
                           </a:solidFill>
@@ -15846,7 +15846,7 @@
                         </a:rPr>
                         <a:t>Maison</a:t>
                       </a:r>
-                      <a:endParaRPr lang="en-US" sz="1600" dirty="0">
+                      <a:endParaRPr lang="en-US" sz="1800" dirty="0">
                         <a:latin typeface="Source Sans 3" charset="0"/>
                         <a:ea typeface="Source Sans 3" charset="0"/>
                         <a:cs typeface="Source Sans 3" charset="0"/>
@@ -15901,7 +15901,7 @@
                         <a:buNone/>
                       </a:pPr>
                       <a:r>
-                        <a:rPr lang="en-US" sz="1600" dirty="0">
+                        <a:rPr lang="en-US" sz="1800" dirty="0">
                           <a:solidFill>
                             <a:srgbClr val="C8261D"/>
                           </a:solidFill>
@@ -15911,7 +15911,7 @@
                         </a:rPr>
                         <a:t>12</a:t>
                       </a:r>
-                      <a:endParaRPr lang="en-US" sz="1600" dirty="0">
+                      <a:endParaRPr lang="en-US" sz="1800" dirty="0">
                         <a:latin typeface="Source Sans 3" charset="0"/>
                         <a:ea typeface="Source Sans 3" charset="0"/>
                         <a:cs typeface="Source Sans 3" charset="0"/>
@@ -15958,7 +15958,7 @@
                   </a:tcPr>
                 </a:tc>
               </a:tr>
-              <a:tr h="329184">
+              <a:tr h="365760">
                 <a:tc>
                   <a:txBody>
                     <a:bodyPr/>
@@ -15968,7 +15968,7 @@
                         <a:buNone/>
                       </a:pPr>
                       <a:r>
-                        <a:rPr lang="en-US" sz="1600" dirty="0">
+                        <a:rPr lang="en-US" sz="1800" dirty="0">
                           <a:solidFill>
                             <a:srgbClr val="222222"/>
                           </a:solidFill>
@@ -15978,7 +15978,7 @@
                         </a:rPr>
                         <a:t>Textile</a:t>
                       </a:r>
-                      <a:endParaRPr lang="en-US" sz="1600" dirty="0">
+                      <a:endParaRPr lang="en-US" sz="1800" dirty="0">
                         <a:latin typeface="Source Sans 3" charset="0"/>
                         <a:ea typeface="Source Sans 3" charset="0"/>
                         <a:cs typeface="Source Sans 3" charset="0"/>
@@ -16033,7 +16033,7 @@
                         <a:buNone/>
                       </a:pPr>
                       <a:r>
-                        <a:rPr lang="en-US" sz="1600" dirty="0">
+                        <a:rPr lang="en-US" sz="1800" dirty="0">
                           <a:solidFill>
                             <a:srgbClr val="C8261D"/>
                           </a:solidFill>
@@ -16043,7 +16043,7 @@
                         </a:rPr>
                         <a:t>12</a:t>
                       </a:r>
-                      <a:endParaRPr lang="en-US" sz="1600" dirty="0">
+                      <a:endParaRPr lang="en-US" sz="1800" dirty="0">
                         <a:latin typeface="Source Sans 3" charset="0"/>
                         <a:ea typeface="Source Sans 3" charset="0"/>
                         <a:cs typeface="Source Sans 3" charset="0"/>
@@ -20472,7 +20472,7 @@
               <a:buNone/>
             </a:pPr>
             <a:r>
-              <a:rPr lang="en-US" sz="1600" dirty="0">
+              <a:rPr lang="en-US" sz="1800" dirty="0">
                 <a:solidFill>
                   <a:srgbClr val="C8261D"/>
                 </a:solidFill>
@@ -20482,7 +20482,7 @@
               </a:rPr>
               <a:t>La somme des Montant des seules lignes de Casablanca.</a:t>
             </a:r>
-            <a:endParaRPr lang="en-US" sz="1600" dirty="0"/>
+            <a:endParaRPr lang="en-US" sz="1800" dirty="0"/>
           </a:p>
         </p:txBody>
       </p:sp>
@@ -22279,7 +22279,7 @@
               <a:buNone/>
             </a:pPr>
             <a:r>
-              <a:rPr lang="en-US" sz="1700" dirty="0">
+              <a:rPr lang="en-US" sz="1800" dirty="0">
                 <a:solidFill>
                   <a:srgbClr val="0B4F4A"/>
                 </a:solidFill>
@@ -22289,7 +22289,7 @@
               </a:rPr>
               <a:t>févr. +31 %</a:t>
             </a:r>
-            <a:endParaRPr lang="en-US" sz="1700" dirty="0"/>
+            <a:endParaRPr lang="en-US" sz="1800" dirty="0"/>
           </a:p>
         </p:txBody>
       </p:sp>
@@ -22318,7 +22318,7 @@
               <a:buNone/>
             </a:pPr>
             <a:r>
-              <a:rPr lang="en-US" sz="1700" dirty="0">
+              <a:rPr lang="en-US" sz="1800" dirty="0">
                 <a:solidFill>
                   <a:srgbClr val="C8261D"/>
                 </a:solidFill>
@@ -22328,7 +22328,7 @@
               </a:rPr>
               <a:t>mars −26 %</a:t>
             </a:r>
-            <a:endParaRPr lang="en-US" sz="1700" dirty="0"/>
+            <a:endParaRPr lang="en-US" sz="1800" dirty="0"/>
           </a:p>
         </p:txBody>
       </p:sp>
@@ -24181,7 +24181,7 @@
         <p:spPr>
           <a:xfrm>
             <a:off x="8275320" y="5257800"/>
-            <a:ext cx="3337560" cy="1048512"/>
+            <a:ext cx="3337560" cy="896112"/>
           </a:xfrm>
           <a:prstGeom prst="rect">
             <a:avLst/>
@@ -24197,7 +24197,7 @@
               <a:buNone/>
             </a:pPr>
             <a:r>
-              <a:rPr lang="en-US" sz="1600" dirty="0">
+              <a:rPr lang="en-US" sz="1800" dirty="0">
                 <a:solidFill>
                   <a:srgbClr val="5E5E5E"/>
                 </a:solidFill>
@@ -24205,9 +24205,9 @@
                 <a:ea typeface="Source Sans 3" pitchFamily="34" charset="-122"/>
                 <a:cs typeface="Source Sans 3" pitchFamily="34" charset="-120"/>
               </a:rPr>
-              <a:t>Un clic sur une barre filtre toute la page. Format &gt; Modifier les interactions pour choisir qui filtre qui.</a:t>
-            </a:r>
-            <a:endParaRPr lang="en-US" sz="1600" dirty="0"/>
+              <a:t>Un clic sur une barre filtre la page. Format &gt; Modifier les interactions.</a:t>
+            </a:r>
+            <a:endParaRPr lang="en-US" sz="1800" dirty="0"/>
           </a:p>
         </p:txBody>
       </p:sp>
@@ -25177,7 +25177,7 @@
               <a:buNone/>
             </a:pPr>
             <a:r>
-              <a:rPr lang="en-US" sz="1600" dirty="0">
+              <a:rPr lang="en-US" sz="1800" dirty="0">
                 <a:solidFill>
                   <a:srgbClr val="C8261D"/>
                 </a:solidFill>
@@ -25187,7 +25187,7 @@
               </a:rPr>
               <a:t>Au 30/09 ce matin. Dans dix minutes : au 11/10.</a:t>
             </a:r>
-            <a:endParaRPr lang="en-US" sz="1600" dirty="0"/>
+            <a:endParaRPr lang="en-US" sz="1800" dirty="0"/>
           </a:p>
         </p:txBody>
       </p:sp>
@@ -27570,7 +27570,7 @@
               <a:buNone/>
             </a:pPr>
             <a:r>
-              <a:rPr lang="en-US" sz="1700" dirty="0">
+              <a:rPr lang="en-US" sz="1800" dirty="0">
                 <a:solidFill>
                   <a:srgbClr val="C8261D"/>
                 </a:solidFill>
@@ -27580,7 +27580,7 @@
               </a:rPr>
               <a:t>Vue Rapport, vue Table, vue Modèle. Les deux icônes du bas (requête DAX, TMDL) ne servent pas aujourd’hui.</a:t>
             </a:r>
-            <a:endParaRPr lang="en-US" sz="1700" dirty="0"/>
+            <a:endParaRPr lang="en-US" sz="1800" dirty="0"/>
           </a:p>
         </p:txBody>
       </p:sp>
@@ -27633,7 +27633,7 @@
               <a:buNone/>
             </a:pPr>
             <a:r>
-              <a:rPr lang="en-US" sz="1700" dirty="0">
+              <a:rPr lang="en-US" sz="1800" dirty="0">
                 <a:solidFill>
                   <a:srgbClr val="C8261D"/>
                 </a:solidFill>
@@ -27643,7 +27643,7 @@
               </a:rPr>
               <a:t>Filtres, Visualisations et Données : ce qui sert à construire une page.</a:t>
             </a:r>
-            <a:endParaRPr lang="en-US" sz="1700" dirty="0"/>
+            <a:endParaRPr lang="en-US" sz="1800" dirty="0"/>
           </a:p>
         </p:txBody>
       </p:sp>

</xml_diff>